<commit_message>
Agregar transiciones entre diapositivas
La libreria que genera el archivo no escribe transiciones, asi que se
insertan en el XML de cada diapositiva, despues de p:clrMapOvr, que es
donde el formato OOXML las exige.

Cada transicion se escribe por duplicado: la version moderna para
PowerPoint 2016 en adelante y una equivalente clasica como respaldo,
para que la presentacion tambien funcione en versiones antiguas.

  fundido    en las paginas de contenido
  morph      entre los modulos, para que la ventana se desplace sola
  cover      al entrar a cada seccion, subiendo desde abajo

Co-Authored-By: Claude Opus 5 <noreply@anthropic.com>
Claude-Session: https://claude.ai/code/session_01Q8Q1XapGYKsQRUFwrqVKME
</commit_message>
<xml_diff>
--- a/Presentacion/Sistema_de_Estudio_PUCE.pptx
+++ b/Presentacion/Sistema_de_Estudio_PUCE.pptx
@@ -2459,6 +2459,18 @@
   <p:clrMapOvr>
     <a:masterClrMapping/>
   </p:clrMapOvr>
+  <mc:AlternateContent xmlns:mc="http://schemas.openxmlformats.org/markup-compatibility/2006">
+    <mc:Choice xmlns:p14="http://schemas.microsoft.com/office/powerpoint/2010/main" Requires="p14">
+      <p:transition spd="slow" p14:dur="800">
+        <p:fade/>
+      </p:transition>
+    </mc:Choice>
+    <mc:Fallback>
+      <p:transition spd="slow">
+        <p:fade/>
+      </p:transition>
+    </mc:Fallback>
+  </mc:AlternateContent>
 </p:sld>
 </file>
 
@@ -2691,6 +2703,18 @@
   <p:clrMapOvr>
     <a:masterClrMapping/>
   </p:clrMapOvr>
+  <mc:AlternateContent xmlns:mc="http://schemas.openxmlformats.org/markup-compatibility/2006">
+    <mc:Choice xmlns:p14="http://schemas.microsoft.com/office/powerpoint/2010/main" Requires="p14">
+      <p:transition spd="slow" p14:dur="900">
+        <p:cover dir="u"/>
+      </p:transition>
+    </mc:Choice>
+    <mc:Fallback>
+      <p:transition spd="slow">
+        <p:cover dir="u"/>
+      </p:transition>
+    </mc:Fallback>
+  </mc:AlternateContent>
 </p:sld>
 </file>
 
@@ -3945,6 +3969,18 @@
   <p:clrMapOvr>
     <a:masterClrMapping/>
   </p:clrMapOvr>
+  <mc:AlternateContent xmlns:mc="http://schemas.openxmlformats.org/markup-compatibility/2006">
+    <mc:Choice xmlns:p14="http://schemas.microsoft.com/office/powerpoint/2010/main" Requires="p14">
+      <p:transition spd="slow" p14:dur="800">
+        <p:fade/>
+      </p:transition>
+    </mc:Choice>
+    <mc:Fallback>
+      <p:transition spd="slow">
+        <p:fade/>
+      </p:transition>
+    </mc:Fallback>
+  </mc:AlternateContent>
 </p:sld>
 </file>
 
@@ -5434,6 +5470,18 @@
   <p:clrMapOvr>
     <a:masterClrMapping/>
   </p:clrMapOvr>
+  <mc:AlternateContent xmlns:mc="http://schemas.openxmlformats.org/markup-compatibility/2006">
+    <mc:Choice xmlns:p14="http://schemas.microsoft.com/office/powerpoint/2010/main" Requires="p14">
+      <p:transition spd="slow" p14:dur="800">
+        <p:fade/>
+      </p:transition>
+    </mc:Choice>
+    <mc:Fallback>
+      <p:transition spd="slow">
+        <p:fade/>
+      </p:transition>
+    </mc:Fallback>
+  </mc:AlternateContent>
 </p:sld>
 </file>
 
@@ -6559,6 +6607,18 @@
   <p:clrMapOvr>
     <a:masterClrMapping/>
   </p:clrMapOvr>
+  <mc:AlternateContent xmlns:mc="http://schemas.openxmlformats.org/markup-compatibility/2006">
+    <mc:Choice xmlns:p14="http://schemas.microsoft.com/office/powerpoint/2010/main" Requires="p14">
+      <p:transition spd="slow" p14:dur="800">
+        <p:fade/>
+      </p:transition>
+    </mc:Choice>
+    <mc:Fallback>
+      <p:transition spd="slow">
+        <p:fade/>
+      </p:transition>
+    </mc:Fallback>
+  </mc:AlternateContent>
 </p:sld>
 </file>
 
@@ -7357,6 +7417,18 @@
   <p:clrMapOvr>
     <a:masterClrMapping/>
   </p:clrMapOvr>
+  <mc:AlternateContent xmlns:mc="http://schemas.openxmlformats.org/markup-compatibility/2006">
+    <mc:Choice xmlns:p14="http://schemas.microsoft.com/office/powerpoint/2010/main" Requires="p14">
+      <p:transition spd="slow" p14:dur="800">
+        <p:fade/>
+      </p:transition>
+    </mc:Choice>
+    <mc:Fallback>
+      <p:transition spd="slow">
+        <p:fade/>
+      </p:transition>
+    </mc:Fallback>
+  </mc:AlternateContent>
 </p:sld>
 </file>
 
@@ -8000,6 +8072,18 @@
   <p:clrMapOvr>
     <a:masterClrMapping/>
   </p:clrMapOvr>
+  <mc:AlternateContent xmlns:mc="http://schemas.openxmlformats.org/markup-compatibility/2006">
+    <mc:Choice xmlns:p14="http://schemas.microsoft.com/office/powerpoint/2010/main" Requires="p14">
+      <p:transition spd="slow" p14:dur="800">
+        <p:fade/>
+      </p:transition>
+    </mc:Choice>
+    <mc:Fallback>
+      <p:transition spd="slow">
+        <p:fade/>
+      </p:transition>
+    </mc:Fallback>
+  </mc:AlternateContent>
 </p:sld>
 </file>
 
@@ -9026,6 +9110,18 @@
   <p:clrMapOvr>
     <a:masterClrMapping/>
   </p:clrMapOvr>
+  <mc:AlternateContent xmlns:mc="http://schemas.openxmlformats.org/markup-compatibility/2006">
+    <mc:Choice xmlns:p14="http://schemas.microsoft.com/office/powerpoint/2010/main" Requires="p14">
+      <p:transition spd="slow" p14:dur="800">
+        <p:fade/>
+      </p:transition>
+    </mc:Choice>
+    <mc:Fallback>
+      <p:transition spd="slow">
+        <p:fade/>
+      </p:transition>
+    </mc:Fallback>
+  </mc:AlternateContent>
 </p:sld>
 </file>
 
@@ -9929,6 +10025,18 @@
   <p:clrMapOvr>
     <a:masterClrMapping/>
   </p:clrMapOvr>
+  <mc:AlternateContent xmlns:mc="http://schemas.openxmlformats.org/markup-compatibility/2006">
+    <mc:Choice xmlns:p14="http://schemas.microsoft.com/office/powerpoint/2010/main" Requires="p14">
+      <p:transition spd="slow" p14:dur="800">
+        <p:fade/>
+      </p:transition>
+    </mc:Choice>
+    <mc:Fallback>
+      <p:transition spd="slow">
+        <p:fade/>
+      </p:transition>
+    </mc:Fallback>
+  </mc:AlternateContent>
 </p:sld>
 </file>
 
@@ -10161,6 +10269,18 @@
   <p:clrMapOvr>
     <a:masterClrMapping/>
   </p:clrMapOvr>
+  <mc:AlternateContent xmlns:mc="http://schemas.openxmlformats.org/markup-compatibility/2006">
+    <mc:Choice xmlns:p14="http://schemas.microsoft.com/office/powerpoint/2010/main" Requires="p14">
+      <p:transition spd="slow" p14:dur="900">
+        <p:cover dir="u"/>
+      </p:transition>
+    </mc:Choice>
+    <mc:Fallback>
+      <p:transition spd="slow">
+        <p:cover dir="u"/>
+      </p:transition>
+    </mc:Fallback>
+  </mc:AlternateContent>
 </p:sld>
 </file>
 
@@ -11011,6 +11131,18 @@
   <p:clrMapOvr>
     <a:masterClrMapping/>
   </p:clrMapOvr>
+  <mc:AlternateContent xmlns:mc="http://schemas.openxmlformats.org/markup-compatibility/2006">
+    <mc:Choice xmlns:p14="http://schemas.microsoft.com/office/powerpoint/2010/main" Requires="p14">
+      <p:transition spd="slow" p14:dur="800">
+        <p:fade/>
+      </p:transition>
+    </mc:Choice>
+    <mc:Fallback>
+      <p:transition spd="slow">
+        <p:fade/>
+      </p:transition>
+    </mc:Fallback>
+  </mc:AlternateContent>
 </p:sld>
 </file>
 
@@ -11804,6 +11936,18 @@
   <p:clrMapOvr>
     <a:masterClrMapping/>
   </p:clrMapOvr>
+  <mc:AlternateContent xmlns:mc="http://schemas.openxmlformats.org/markup-compatibility/2006">
+    <mc:Choice xmlns:p14="http://schemas.microsoft.com/office/powerpoint/2010/main" Requires="p14">
+      <p:transition spd="slow" p14:dur="900">
+        <p14:morph option="byObject"/>
+      </p:transition>
+    </mc:Choice>
+    <mc:Fallback>
+      <p:transition spd="slow">
+        <p:fade/>
+      </p:transition>
+    </mc:Fallback>
+  </mc:AlternateContent>
 </p:sld>
 </file>
 
@@ -12450,6 +12594,18 @@
   <p:clrMapOvr>
     <a:masterClrMapping/>
   </p:clrMapOvr>
+  <mc:AlternateContent xmlns:mc="http://schemas.openxmlformats.org/markup-compatibility/2006">
+    <mc:Choice xmlns:p14="http://schemas.microsoft.com/office/powerpoint/2010/main" Requires="p14">
+      <p:transition spd="slow" p14:dur="900">
+        <p14:morph option="byObject"/>
+      </p:transition>
+    </mc:Choice>
+    <mc:Fallback>
+      <p:transition spd="slow">
+        <p:fade/>
+      </p:transition>
+    </mc:Fallback>
+  </mc:AlternateContent>
 </p:sld>
 </file>
 
@@ -13378,6 +13534,18 @@
   <p:clrMapOvr>
     <a:masterClrMapping/>
   </p:clrMapOvr>
+  <mc:AlternateContent xmlns:mc="http://schemas.openxmlformats.org/markup-compatibility/2006">
+    <mc:Choice xmlns:p14="http://schemas.microsoft.com/office/powerpoint/2010/main" Requires="p14">
+      <p:transition spd="slow" p14:dur="900">
+        <p14:morph option="byObject"/>
+      </p:transition>
+    </mc:Choice>
+    <mc:Fallback>
+      <p:transition spd="slow">
+        <p:fade/>
+      </p:transition>
+    </mc:Fallback>
+  </mc:AlternateContent>
 </p:sld>
 </file>
 
@@ -14185,6 +14353,18 @@
   <p:clrMapOvr>
     <a:masterClrMapping/>
   </p:clrMapOvr>
+  <mc:AlternateContent xmlns:mc="http://schemas.openxmlformats.org/markup-compatibility/2006">
+    <mc:Choice xmlns:p14="http://schemas.microsoft.com/office/powerpoint/2010/main" Requires="p14">
+      <p:transition spd="slow" p14:dur="800">
+        <p:fade/>
+      </p:transition>
+    </mc:Choice>
+    <mc:Fallback>
+      <p:transition spd="slow">
+        <p:fade/>
+      </p:transition>
+    </mc:Fallback>
+  </mc:AlternateContent>
 </p:sld>
 </file>
 

</xml_diff>